<commit_message>
LLVM document link update
</commit_message>
<xml_diff>
--- a/3-clang-llvm/lec13-llvm-pass-v4.pptx
+++ b/3-clang-llvm/lec13-llvm-pass-v4.pptx
@@ -24811,9 +24811,12 @@
           <a:p>
             <a:pPr lvl="1"/>
             <a:r>
-              <a:rPr lang="en-US" altLang="ko-KR" sz="2000" dirty="0"/>
-              <a:t>http://llvm.org/docs/WritingAnLLVMPass.html</a:t>
-            </a:r>
+              <a:rPr lang="en-US" altLang="ko-KR" sz="2000" dirty="0">
+                <a:hlinkClick r:id="rId2"/>
+              </a:rPr>
+              <a:t>https://llvm.org/docs/WritingAnLLVMNewPMPass.html</a:t>
+            </a:r>
+            <a:endParaRPr lang="en-US" altLang="ko-KR" sz="2000" dirty="0"/>
           </a:p>
           <a:p>
             <a:pPr lvl="1"/>

</xml_diff>